<commit_message>
implementacion de metodos de recomendacion y clasificacion 3
</commit_message>
<xml_diff>
--- a/outputs/Propuestas_analitica_Distribuidora_Panamericana_campos_completos.pptx
+++ b/outputs/Propuestas_analitica_Distribuidora_Panamericana_campos_completos.pptx
@@ -3711,8 +3711,8 @@
         </p:nvSpPr>
         <p:spPr>
           <a:xfrm>
-            <a:off x="8496300" y="2095500"/>
-            <a:ext cx="495300" cy="266700"/>
+            <a:off x="8458199" y="2095500"/>
+            <a:ext cx="600075" cy="190500"/>
           </a:xfrm>
           <a:prstGeom prst="rect">
             <a:avLst/>
@@ -3735,13 +3735,18 @@
               </a:defRPr>
             </a:pPr>
             <a:r>
-              <a:rPr sz="1125" b="1">
+              <a:rPr sz="1125" b="1" dirty="0" err="1">
                 <a:solidFill>
                   <a:srgbClr val="27643A"/>
                 </a:solidFill>
               </a:rPr>
               <a:t>precio</a:t>
             </a:r>
+            <a:endParaRPr sz="1125" b="1" dirty="0">
+              <a:solidFill>
+                <a:srgbClr val="27643A"/>
+              </a:solidFill>
+            </a:endParaRPr>
           </a:p>
         </p:txBody>
       </p:sp>

</xml_diff>